<commit_message>
Final Presentation - Final
</commit_message>
<xml_diff>
--- a/Zone_Store_Analysis.pptx
+++ b/Zone_Store_Analysis.pptx
@@ -15,9 +15,9 @@
     <p:sldId id="269" r:id="rId9"/>
     <p:sldId id="270" r:id="rId10"/>
     <p:sldId id="265" r:id="rId11"/>
-    <p:sldId id="266" r:id="rId12"/>
-    <p:sldId id="271" r:id="rId13"/>
-    <p:sldId id="272" r:id="rId14"/>
+    <p:sldId id="271" r:id="rId12"/>
+    <p:sldId id="272" r:id="rId13"/>
+    <p:sldId id="266" r:id="rId14"/>
     <p:sldId id="268" r:id="rId15"/>
     <p:sldId id="260" r:id="rId16"/>
     <p:sldId id="261" r:id="rId17"/>
@@ -26826,303 +26826,6 @@
           <p:cNvPr id="2" name="Title 1">
             <a:extLst>
               <a:ext uri="{FF2B5EF4-FFF2-40B4-BE49-F238E27FC236}">
-                <a16:creationId xmlns:a16="http://schemas.microsoft.com/office/drawing/2014/main" id="{E32BCB07-9105-4561-854F-3EE6CECF99A7}"/>
-              </a:ext>
-            </a:extLst>
-          </p:cNvPr>
-          <p:cNvSpPr>
-            <a:spLocks noGrp="1"/>
-          </p:cNvSpPr>
-          <p:nvPr>
-            <p:ph type="title"/>
-          </p:nvPr>
-        </p:nvSpPr>
-        <p:spPr>
-          <a:xfrm>
-            <a:off x="768100" y="822960"/>
-            <a:ext cx="3363329" cy="891778"/>
-          </a:xfrm>
-        </p:spPr>
-        <p:txBody>
-          <a:bodyPr/>
-          <a:lstStyle/>
-          <a:p>
-            <a:r>
-              <a:rPr lang="en-US" b="1" dirty="0"/>
-              <a:t>Python</a:t>
-            </a:r>
-          </a:p>
-        </p:txBody>
-      </p:sp>
-      <p:pic>
-        <p:nvPicPr>
-          <p:cNvPr id="7" name="Content Placeholder 6">
-            <a:extLst>
-              <a:ext uri="{FF2B5EF4-FFF2-40B4-BE49-F238E27FC236}">
-                <a16:creationId xmlns:a16="http://schemas.microsoft.com/office/drawing/2014/main" id="{BF28E972-557F-4116-BB0F-B3C0CE20DD64}"/>
-              </a:ext>
-            </a:extLst>
-          </p:cNvPr>
-          <p:cNvPicPr>
-            <a:picLocks noGrp="1" noChangeAspect="1"/>
-          </p:cNvPicPr>
-          <p:nvPr>
-            <p:ph idx="1"/>
-          </p:nvPr>
-        </p:nvPicPr>
-        <p:blipFill>
-          <a:blip r:embed="rId2"/>
-          <a:stretch>
-            <a:fillRect/>
-          </a:stretch>
-        </p:blipFill>
-        <p:spPr>
-          <a:xfrm>
-            <a:off x="4286254" y="266010"/>
-            <a:ext cx="4705047" cy="2967645"/>
-          </a:xfrm>
-          <a:ln>
-            <a:solidFill>
-              <a:schemeClr val="accent1"/>
-            </a:solidFill>
-          </a:ln>
-          <a:effectLst>
-            <a:glow rad="25400">
-              <a:schemeClr val="accent2">
-                <a:satMod val="175000"/>
-                <a:alpha val="40000"/>
-              </a:schemeClr>
-            </a:glow>
-          </a:effectLst>
-        </p:spPr>
-      </p:pic>
-      <p:sp>
-        <p:nvSpPr>
-          <p:cNvPr id="5" name="Arrow: Right 4">
-            <a:hlinkClick r:id="rId3" action="ppaction://hlinksldjump" highlightClick="1"/>
-            <a:extLst>
-              <a:ext uri="{FF2B5EF4-FFF2-40B4-BE49-F238E27FC236}">
-                <a16:creationId xmlns:a16="http://schemas.microsoft.com/office/drawing/2014/main" id="{501492F9-FDEA-4D35-840F-CC8470398996}"/>
-              </a:ext>
-            </a:extLst>
-          </p:cNvPr>
-          <p:cNvSpPr/>
-          <p:nvPr/>
-        </p:nvSpPr>
-        <p:spPr>
-          <a:xfrm rot="10800000">
-            <a:off x="152124" y="6367552"/>
-            <a:ext cx="410649" cy="382385"/>
-          </a:xfrm>
-          <a:prstGeom prst="rightArrow">
-            <a:avLst/>
-          </a:prstGeom>
-        </p:spPr>
-        <p:style>
-          <a:lnRef idx="2">
-            <a:schemeClr val="accent1">
-              <a:shade val="50000"/>
-            </a:schemeClr>
-          </a:lnRef>
-          <a:fillRef idx="1">
-            <a:schemeClr val="accent1"/>
-          </a:fillRef>
-          <a:effectRef idx="0">
-            <a:schemeClr val="accent1"/>
-          </a:effectRef>
-          <a:fontRef idx="minor">
-            <a:schemeClr val="lt1"/>
-          </a:fontRef>
-        </p:style>
-        <p:txBody>
-          <a:bodyPr rtlCol="0" anchor="ctr"/>
-          <a:lstStyle/>
-          <a:p>
-            <a:pPr algn="ctr"/>
-            <a:endParaRPr lang="en-US"/>
-          </a:p>
-        </p:txBody>
-      </p:sp>
-      <p:pic>
-        <p:nvPicPr>
-          <p:cNvPr id="10" name="Picture 9">
-            <a:extLst>
-              <a:ext uri="{FF2B5EF4-FFF2-40B4-BE49-F238E27FC236}">
-                <a16:creationId xmlns:a16="http://schemas.microsoft.com/office/drawing/2014/main" id="{47A8315B-3D51-445E-AD68-C9DEAFFD66FF}"/>
-              </a:ext>
-            </a:extLst>
-          </p:cNvPr>
-          <p:cNvPicPr>
-            <a:picLocks noChangeAspect="1"/>
-          </p:cNvPicPr>
-          <p:nvPr/>
-        </p:nvPicPr>
-        <p:blipFill>
-          <a:blip r:embed="rId4"/>
-          <a:stretch>
-            <a:fillRect/>
-          </a:stretch>
-        </p:blipFill>
-        <p:spPr>
-          <a:xfrm>
-            <a:off x="4286249" y="3429000"/>
-            <a:ext cx="4705048" cy="2863734"/>
-          </a:xfrm>
-          <a:prstGeom prst="rect">
-            <a:avLst/>
-          </a:prstGeom>
-          <a:ln>
-            <a:solidFill>
-              <a:schemeClr val="accent1"/>
-            </a:solidFill>
-          </a:ln>
-          <a:effectLst>
-            <a:glow rad="25400">
-              <a:schemeClr val="accent2">
-                <a:satMod val="175000"/>
-                <a:alpha val="40000"/>
-              </a:schemeClr>
-            </a:glow>
-          </a:effectLst>
-        </p:spPr>
-      </p:pic>
-      <p:pic>
-        <p:nvPicPr>
-          <p:cNvPr id="12" name="Picture 11">
-            <a:extLst>
-              <a:ext uri="{FF2B5EF4-FFF2-40B4-BE49-F238E27FC236}">
-                <a16:creationId xmlns:a16="http://schemas.microsoft.com/office/drawing/2014/main" id="{26CD293B-E737-4369-B35C-88A6B85D8CF9}"/>
-              </a:ext>
-            </a:extLst>
-          </p:cNvPr>
-          <p:cNvPicPr>
-            <a:picLocks noChangeAspect="1"/>
-          </p:cNvPicPr>
-          <p:nvPr/>
-        </p:nvPicPr>
-        <p:blipFill>
-          <a:blip r:embed="rId5"/>
-          <a:stretch>
-            <a:fillRect/>
-          </a:stretch>
-        </p:blipFill>
-        <p:spPr>
-          <a:xfrm>
-            <a:off x="574990" y="4202354"/>
-            <a:ext cx="3564498" cy="2090385"/>
-          </a:xfrm>
-          <a:prstGeom prst="rect">
-            <a:avLst/>
-          </a:prstGeom>
-        </p:spPr>
-      </p:pic>
-      <p:sp>
-        <p:nvSpPr>
-          <p:cNvPr id="20" name="Text Placeholder 3">
-            <a:extLst>
-              <a:ext uri="{FF2B5EF4-FFF2-40B4-BE49-F238E27FC236}">
-                <a16:creationId xmlns:a16="http://schemas.microsoft.com/office/drawing/2014/main" id="{334AE4FD-B142-40C5-8832-9146DD3EACDA}"/>
-              </a:ext>
-            </a:extLst>
-          </p:cNvPr>
-          <p:cNvSpPr>
-            <a:spLocks noGrp="1"/>
-          </p:cNvSpPr>
-          <p:nvPr>
-            <p:ph type="body" sz="half" idx="2"/>
-          </p:nvPr>
-        </p:nvSpPr>
-        <p:spPr>
-          <a:xfrm>
-            <a:off x="566927" y="1818919"/>
-            <a:ext cx="3564498" cy="2279259"/>
-          </a:xfrm>
-          <a:ln>
-            <a:solidFill>
-              <a:schemeClr val="accent1"/>
-            </a:solidFill>
-          </a:ln>
-          <a:effectLst/>
-        </p:spPr>
-        <p:txBody>
-          <a:bodyPr>
-            <a:noAutofit/>
-          </a:bodyPr>
-          <a:lstStyle/>
-          <a:p>
-            <a:pPr marL="171450" indent="-171450">
-              <a:buFont typeface="Arial" panose="020B0604020202020204" pitchFamily="34" charset="0"/>
-              <a:buChar char="•"/>
-            </a:pPr>
-            <a:r>
-              <a:rPr lang="en-US" sz="1500" dirty="0"/>
-              <a:t>Used Python (Pandas) to clean the dataset by detecting missing values, removing duplicates, and ensuring data accuracy.</a:t>
-            </a:r>
-          </a:p>
-          <a:p>
-            <a:pPr marL="171450" indent="-171450">
-              <a:buFont typeface="Arial" panose="020B0604020202020204" pitchFamily="34" charset="0"/>
-              <a:buChar char="•"/>
-            </a:pPr>
-            <a:r>
-              <a:rPr lang="en-US" sz="1500" dirty="0"/>
-              <a:t>Inspected the dataset structure using tools to validate correct column data types.</a:t>
-            </a:r>
-          </a:p>
-          <a:p>
-            <a:pPr marL="171450" indent="-171450">
-              <a:buFont typeface="Arial" panose="020B0604020202020204" pitchFamily="34" charset="0"/>
-              <a:buChar char="•"/>
-            </a:pPr>
-            <a:r>
-              <a:rPr lang="en-US" sz="1500" dirty="0"/>
-              <a:t>Exported a fully cleaned and reliable dataset ready for analysis in SQL, Tableau, and Power BI.</a:t>
-            </a:r>
-          </a:p>
-          <a:p>
-            <a:pPr marL="285750" indent="-285750">
-              <a:buFont typeface="Arial" panose="020B0604020202020204" pitchFamily="34" charset="0"/>
-              <a:buChar char="•"/>
-            </a:pPr>
-            <a:endParaRPr lang="en-US" sz="1050" dirty="0"/>
-          </a:p>
-        </p:txBody>
-      </p:sp>
-    </p:spTree>
-    <p:extLst>
-      <p:ext uri="{BB962C8B-B14F-4D97-AF65-F5344CB8AC3E}">
-        <p14:creationId xmlns:p14="http://schemas.microsoft.com/office/powerpoint/2010/main" val="4114017101"/>
-      </p:ext>
-    </p:extLst>
-  </p:cSld>
-  <p:clrMapOvr>
-    <a:masterClrMapping/>
-  </p:clrMapOvr>
-</p:sld>
-</file>
-
-<file path=ppt/slides/slide12.xml><?xml version="1.0" encoding="utf-8"?>
-<p:sld xmlns:a="http://schemas.openxmlformats.org/drawingml/2006/main" xmlns:r="http://schemas.openxmlformats.org/officeDocument/2006/relationships" xmlns:p="http://schemas.openxmlformats.org/presentationml/2006/main">
-  <p:cSld>
-    <p:spTree>
-      <p:nvGrpSpPr>
-        <p:cNvPr id="1" name=""/>
-        <p:cNvGrpSpPr/>
-        <p:nvPr/>
-      </p:nvGrpSpPr>
-      <p:grpSpPr>
-        <a:xfrm>
-          <a:off x="0" y="0"/>
-          <a:ext cx="0" cy="0"/>
-          <a:chOff x="0" y="0"/>
-          <a:chExt cx="0" cy="0"/>
-        </a:xfrm>
-      </p:grpSpPr>
-      <p:sp>
-        <p:nvSpPr>
-          <p:cNvPr id="2" name="Title 1">
-            <a:extLst>
-              <a:ext uri="{FF2B5EF4-FFF2-40B4-BE49-F238E27FC236}">
                 <a16:creationId xmlns:a16="http://schemas.microsoft.com/office/drawing/2014/main" id="{18BDED81-B87B-4AAB-A226-B5DF130F7997}"/>
               </a:ext>
             </a:extLst>
@@ -27476,7 +27179,7 @@
 </p:sld>
 </file>
 
-<file path=ppt/slides/slide13.xml><?xml version="1.0" encoding="utf-8"?>
+<file path=ppt/slides/slide12.xml><?xml version="1.0" encoding="utf-8"?>
 <p:sld xmlns:a="http://schemas.openxmlformats.org/drawingml/2006/main" xmlns:r="http://schemas.openxmlformats.org/officeDocument/2006/relationships" xmlns:p="http://schemas.openxmlformats.org/presentationml/2006/main">
   <p:cSld>
     <p:spTree>
@@ -27790,6 +27493,303 @@
     <p:extLst>
       <p:ext uri="{BB962C8B-B14F-4D97-AF65-F5344CB8AC3E}">
         <p14:creationId xmlns:p14="http://schemas.microsoft.com/office/powerpoint/2010/main" val="3769878043"/>
+      </p:ext>
+    </p:extLst>
+  </p:cSld>
+  <p:clrMapOvr>
+    <a:masterClrMapping/>
+  </p:clrMapOvr>
+</p:sld>
+</file>
+
+<file path=ppt/slides/slide13.xml><?xml version="1.0" encoding="utf-8"?>
+<p:sld xmlns:a="http://schemas.openxmlformats.org/drawingml/2006/main" xmlns:r="http://schemas.openxmlformats.org/officeDocument/2006/relationships" xmlns:p="http://schemas.openxmlformats.org/presentationml/2006/main">
+  <p:cSld>
+    <p:spTree>
+      <p:nvGrpSpPr>
+        <p:cNvPr id="1" name=""/>
+        <p:cNvGrpSpPr/>
+        <p:nvPr/>
+      </p:nvGrpSpPr>
+      <p:grpSpPr>
+        <a:xfrm>
+          <a:off x="0" y="0"/>
+          <a:ext cx="0" cy="0"/>
+          <a:chOff x="0" y="0"/>
+          <a:chExt cx="0" cy="0"/>
+        </a:xfrm>
+      </p:grpSpPr>
+      <p:sp>
+        <p:nvSpPr>
+          <p:cNvPr id="2" name="Title 1">
+            <a:extLst>
+              <a:ext uri="{FF2B5EF4-FFF2-40B4-BE49-F238E27FC236}">
+                <a16:creationId xmlns:a16="http://schemas.microsoft.com/office/drawing/2014/main" id="{E32BCB07-9105-4561-854F-3EE6CECF99A7}"/>
+              </a:ext>
+            </a:extLst>
+          </p:cNvPr>
+          <p:cNvSpPr>
+            <a:spLocks noGrp="1"/>
+          </p:cNvSpPr>
+          <p:nvPr>
+            <p:ph type="title"/>
+          </p:nvPr>
+        </p:nvSpPr>
+        <p:spPr>
+          <a:xfrm>
+            <a:off x="768100" y="822960"/>
+            <a:ext cx="3363329" cy="891778"/>
+          </a:xfrm>
+        </p:spPr>
+        <p:txBody>
+          <a:bodyPr/>
+          <a:lstStyle/>
+          <a:p>
+            <a:r>
+              <a:rPr lang="en-US" b="1" dirty="0"/>
+              <a:t>Python</a:t>
+            </a:r>
+          </a:p>
+        </p:txBody>
+      </p:sp>
+      <p:pic>
+        <p:nvPicPr>
+          <p:cNvPr id="7" name="Content Placeholder 6">
+            <a:extLst>
+              <a:ext uri="{FF2B5EF4-FFF2-40B4-BE49-F238E27FC236}">
+                <a16:creationId xmlns:a16="http://schemas.microsoft.com/office/drawing/2014/main" id="{BF28E972-557F-4116-BB0F-B3C0CE20DD64}"/>
+              </a:ext>
+            </a:extLst>
+          </p:cNvPr>
+          <p:cNvPicPr>
+            <a:picLocks noGrp="1" noChangeAspect="1"/>
+          </p:cNvPicPr>
+          <p:nvPr>
+            <p:ph idx="1"/>
+          </p:nvPr>
+        </p:nvPicPr>
+        <p:blipFill>
+          <a:blip r:embed="rId2"/>
+          <a:stretch>
+            <a:fillRect/>
+          </a:stretch>
+        </p:blipFill>
+        <p:spPr>
+          <a:xfrm>
+            <a:off x="4286254" y="266010"/>
+            <a:ext cx="4705047" cy="2967645"/>
+          </a:xfrm>
+          <a:ln>
+            <a:solidFill>
+              <a:schemeClr val="accent1"/>
+            </a:solidFill>
+          </a:ln>
+          <a:effectLst>
+            <a:glow rad="25400">
+              <a:schemeClr val="accent2">
+                <a:satMod val="175000"/>
+                <a:alpha val="40000"/>
+              </a:schemeClr>
+            </a:glow>
+          </a:effectLst>
+        </p:spPr>
+      </p:pic>
+      <p:sp>
+        <p:nvSpPr>
+          <p:cNvPr id="5" name="Arrow: Right 4">
+            <a:hlinkClick r:id="rId3" action="ppaction://hlinksldjump" highlightClick="1"/>
+            <a:extLst>
+              <a:ext uri="{FF2B5EF4-FFF2-40B4-BE49-F238E27FC236}">
+                <a16:creationId xmlns:a16="http://schemas.microsoft.com/office/drawing/2014/main" id="{501492F9-FDEA-4D35-840F-CC8470398996}"/>
+              </a:ext>
+            </a:extLst>
+          </p:cNvPr>
+          <p:cNvSpPr/>
+          <p:nvPr/>
+        </p:nvSpPr>
+        <p:spPr>
+          <a:xfrm rot="10800000">
+            <a:off x="152124" y="6367552"/>
+            <a:ext cx="410649" cy="382385"/>
+          </a:xfrm>
+          <a:prstGeom prst="rightArrow">
+            <a:avLst/>
+          </a:prstGeom>
+        </p:spPr>
+        <p:style>
+          <a:lnRef idx="2">
+            <a:schemeClr val="accent1">
+              <a:shade val="50000"/>
+            </a:schemeClr>
+          </a:lnRef>
+          <a:fillRef idx="1">
+            <a:schemeClr val="accent1"/>
+          </a:fillRef>
+          <a:effectRef idx="0">
+            <a:schemeClr val="accent1"/>
+          </a:effectRef>
+          <a:fontRef idx="minor">
+            <a:schemeClr val="lt1"/>
+          </a:fontRef>
+        </p:style>
+        <p:txBody>
+          <a:bodyPr rtlCol="0" anchor="ctr"/>
+          <a:lstStyle/>
+          <a:p>
+            <a:pPr algn="ctr"/>
+            <a:endParaRPr lang="en-US"/>
+          </a:p>
+        </p:txBody>
+      </p:sp>
+      <p:pic>
+        <p:nvPicPr>
+          <p:cNvPr id="10" name="Picture 9">
+            <a:extLst>
+              <a:ext uri="{FF2B5EF4-FFF2-40B4-BE49-F238E27FC236}">
+                <a16:creationId xmlns:a16="http://schemas.microsoft.com/office/drawing/2014/main" id="{47A8315B-3D51-445E-AD68-C9DEAFFD66FF}"/>
+              </a:ext>
+            </a:extLst>
+          </p:cNvPr>
+          <p:cNvPicPr>
+            <a:picLocks noChangeAspect="1"/>
+          </p:cNvPicPr>
+          <p:nvPr/>
+        </p:nvPicPr>
+        <p:blipFill>
+          <a:blip r:embed="rId4"/>
+          <a:stretch>
+            <a:fillRect/>
+          </a:stretch>
+        </p:blipFill>
+        <p:spPr>
+          <a:xfrm>
+            <a:off x="4286249" y="3429000"/>
+            <a:ext cx="4705048" cy="2863734"/>
+          </a:xfrm>
+          <a:prstGeom prst="rect">
+            <a:avLst/>
+          </a:prstGeom>
+          <a:ln>
+            <a:solidFill>
+              <a:schemeClr val="accent1"/>
+            </a:solidFill>
+          </a:ln>
+          <a:effectLst>
+            <a:glow rad="25400">
+              <a:schemeClr val="accent2">
+                <a:satMod val="175000"/>
+                <a:alpha val="40000"/>
+              </a:schemeClr>
+            </a:glow>
+          </a:effectLst>
+        </p:spPr>
+      </p:pic>
+      <p:pic>
+        <p:nvPicPr>
+          <p:cNvPr id="12" name="Picture 11">
+            <a:extLst>
+              <a:ext uri="{FF2B5EF4-FFF2-40B4-BE49-F238E27FC236}">
+                <a16:creationId xmlns:a16="http://schemas.microsoft.com/office/drawing/2014/main" id="{26CD293B-E737-4369-B35C-88A6B85D8CF9}"/>
+              </a:ext>
+            </a:extLst>
+          </p:cNvPr>
+          <p:cNvPicPr>
+            <a:picLocks noChangeAspect="1"/>
+          </p:cNvPicPr>
+          <p:nvPr/>
+        </p:nvPicPr>
+        <p:blipFill>
+          <a:blip r:embed="rId5"/>
+          <a:stretch>
+            <a:fillRect/>
+          </a:stretch>
+        </p:blipFill>
+        <p:spPr>
+          <a:xfrm>
+            <a:off x="574990" y="4202354"/>
+            <a:ext cx="3564498" cy="2090385"/>
+          </a:xfrm>
+          <a:prstGeom prst="rect">
+            <a:avLst/>
+          </a:prstGeom>
+        </p:spPr>
+      </p:pic>
+      <p:sp>
+        <p:nvSpPr>
+          <p:cNvPr id="20" name="Text Placeholder 3">
+            <a:extLst>
+              <a:ext uri="{FF2B5EF4-FFF2-40B4-BE49-F238E27FC236}">
+                <a16:creationId xmlns:a16="http://schemas.microsoft.com/office/drawing/2014/main" id="{334AE4FD-B142-40C5-8832-9146DD3EACDA}"/>
+              </a:ext>
+            </a:extLst>
+          </p:cNvPr>
+          <p:cNvSpPr>
+            <a:spLocks noGrp="1"/>
+          </p:cNvSpPr>
+          <p:nvPr>
+            <p:ph type="body" sz="half" idx="2"/>
+          </p:nvPr>
+        </p:nvSpPr>
+        <p:spPr>
+          <a:xfrm>
+            <a:off x="566927" y="1818919"/>
+            <a:ext cx="3564498" cy="2279259"/>
+          </a:xfrm>
+          <a:ln>
+            <a:solidFill>
+              <a:schemeClr val="accent1"/>
+            </a:solidFill>
+          </a:ln>
+          <a:effectLst/>
+        </p:spPr>
+        <p:txBody>
+          <a:bodyPr>
+            <a:noAutofit/>
+          </a:bodyPr>
+          <a:lstStyle/>
+          <a:p>
+            <a:pPr marL="171450" indent="-171450">
+              <a:buFont typeface="Arial" panose="020B0604020202020204" pitchFamily="34" charset="0"/>
+              <a:buChar char="•"/>
+            </a:pPr>
+            <a:r>
+              <a:rPr lang="en-US" sz="1500" dirty="0"/>
+              <a:t>Used Python (Pandas) to clean the dataset by detecting missing values, removing duplicates, and ensuring data accuracy.</a:t>
+            </a:r>
+          </a:p>
+          <a:p>
+            <a:pPr marL="171450" indent="-171450">
+              <a:buFont typeface="Arial" panose="020B0604020202020204" pitchFamily="34" charset="0"/>
+              <a:buChar char="•"/>
+            </a:pPr>
+            <a:r>
+              <a:rPr lang="en-US" sz="1500" dirty="0"/>
+              <a:t>Inspected the dataset structure using tools to validate correct column data types.</a:t>
+            </a:r>
+          </a:p>
+          <a:p>
+            <a:pPr marL="171450" indent="-171450">
+              <a:buFont typeface="Arial" panose="020B0604020202020204" pitchFamily="34" charset="0"/>
+              <a:buChar char="•"/>
+            </a:pPr>
+            <a:r>
+              <a:rPr lang="en-US" sz="1500" dirty="0"/>
+              <a:t>Exported a fully cleaned and reliable dataset ready for analysis in SQL, Tableau, and Power BI.</a:t>
+            </a:r>
+          </a:p>
+          <a:p>
+            <a:pPr marL="285750" indent="-285750">
+              <a:buFont typeface="Arial" panose="020B0604020202020204" pitchFamily="34" charset="0"/>
+              <a:buChar char="•"/>
+            </a:pPr>
+            <a:endParaRPr lang="en-US" sz="1050" dirty="0"/>
+          </a:p>
+        </p:txBody>
+      </p:sp>
+    </p:spTree>
+    <p:extLst>
+      <p:ext uri="{BB962C8B-B14F-4D97-AF65-F5344CB8AC3E}">
+        <p14:creationId xmlns:p14="http://schemas.microsoft.com/office/powerpoint/2010/main" val="4114017101"/>
       </p:ext>
     </p:extLst>
   </p:cSld>
@@ -30534,7 +30534,7 @@
         </p:blipFill>
         <p:spPr bwMode="auto">
           <a:xfrm>
-            <a:off x="6959576" y="2517544"/>
+            <a:off x="1417665" y="4730961"/>
             <a:ext cx="428625" cy="476250"/>
           </a:xfrm>
           <a:prstGeom prst="rect">
@@ -30676,7 +30676,7 @@
         <p:spPr>
           <a:xfrm>
             <a:off x="6155358" y="3070794"/>
-            <a:ext cx="2037059" cy="923330"/>
+            <a:ext cx="2037059" cy="738664"/>
           </a:xfrm>
           <a:prstGeom prst="rect">
             <a:avLst/>
@@ -30697,7 +30697,7 @@
                 </a:solidFill>
                 <a:latin typeface="Poppins" panose="00000500000000000000" pitchFamily="2" charset="0"/>
               </a:rPr>
-              <a:t>Python</a:t>
+              <a:t>Tableau</a:t>
             </a:r>
             <a:endParaRPr lang="en-US" dirty="0"/>
           </a:p>
@@ -30710,7 +30710,7 @@
                 </a:solidFill>
                 <a:latin typeface="Lato" panose="020F0502020204030203" pitchFamily="34" charset="0"/>
               </a:rPr>
-              <a:t>Advanced statistical analysis and data preprocessing.</a:t>
+              <a:t>Interactive exploratory data visualizations.</a:t>
             </a:r>
             <a:endParaRPr lang="en-US" sz="1200" dirty="0"/>
           </a:p>
@@ -30745,7 +30745,7 @@
         </p:blipFill>
         <p:spPr bwMode="auto">
           <a:xfrm>
-            <a:off x="1525301" y="4746919"/>
+            <a:off x="6930994" y="2513388"/>
             <a:ext cx="485775" cy="476250"/>
           </a:xfrm>
           <a:prstGeom prst="rect">
@@ -30778,7 +30778,7 @@
         <p:spPr>
           <a:xfrm>
             <a:off x="817422" y="5431393"/>
-            <a:ext cx="1787235" cy="1292662"/>
+            <a:ext cx="1787235" cy="1661993"/>
           </a:xfrm>
           <a:prstGeom prst="rect">
             <a:avLst/>
@@ -30799,7 +30799,7 @@
                 </a:solidFill>
                 <a:latin typeface="Poppins" panose="00000500000000000000" pitchFamily="2" charset="0"/>
               </a:rPr>
-              <a:t>Tableau</a:t>
+              <a:t>Python</a:t>
             </a:r>
             <a:br>
               <a:rPr lang="en-US" sz="1200" dirty="0"/>
@@ -30811,8 +30811,12 @@
                 </a:solidFill>
                 <a:latin typeface="Lato" panose="020F0502020204030203" pitchFamily="34" charset="0"/>
               </a:rPr>
-              <a:t>Interactive exploratory data visualizations.</a:t>
+              <a:t>Advanced statistical analysis and data preprocessing.</a:t>
             </a:r>
+            <a:endParaRPr lang="en-US" sz="1200" dirty="0"/>
+          </a:p>
+          <a:p>
+            <a:pPr algn="ctr"/>
             <a:endParaRPr lang="en-US" sz="1200" dirty="0"/>
           </a:p>
           <a:p>
@@ -30949,7 +30953,7 @@
         </p:nvSpPr>
         <p:spPr>
           <a:xfrm>
-            <a:off x="3376364" y="4453163"/>
+            <a:off x="3376364" y="4512906"/>
             <a:ext cx="2186247" cy="1995363"/>
           </a:xfrm>
           <a:prstGeom prst="roundRect">
@@ -30985,7 +30989,7 @@
           <a:lstStyle/>
           <a:p>
             <a:pPr algn="ctr"/>
-            <a:endParaRPr lang="en-US"/>
+            <a:endParaRPr lang="en-US" dirty="0"/>
           </a:p>
         </p:txBody>
       </p:sp>
@@ -31059,7 +31063,7 @@
         </p:nvSpPr>
         <p:spPr>
           <a:xfrm>
-            <a:off x="6080763" y="2153000"/>
+            <a:off x="617917" y="4512907"/>
             <a:ext cx="2186247" cy="1995363"/>
           </a:xfrm>
           <a:prstGeom prst="roundRect">
@@ -31095,7 +31099,7 @@
           <a:lstStyle/>
           <a:p>
             <a:pPr algn="ctr"/>
-            <a:endParaRPr lang="en-US"/>
+            <a:endParaRPr lang="en-US" dirty="0"/>
           </a:p>
         </p:txBody>
       </p:sp>
@@ -31169,7 +31173,7 @@
         </p:nvSpPr>
         <p:spPr>
           <a:xfrm>
-            <a:off x="619473" y="4453162"/>
+            <a:off x="6021437" y="2153000"/>
             <a:ext cx="2186247" cy="1995363"/>
           </a:xfrm>
           <a:prstGeom prst="roundRect">
@@ -31205,7 +31209,7 @@
           <a:lstStyle/>
           <a:p>
             <a:pPr algn="ctr"/>
-            <a:endParaRPr lang="en-US"/>
+            <a:endParaRPr lang="en-US" dirty="0"/>
           </a:p>
         </p:txBody>
       </p:sp>
@@ -31226,6 +31230,53 @@
           <a:xfrm>
             <a:off x="8533015" y="6367552"/>
             <a:ext cx="411480" cy="384048"/>
+          </a:xfrm>
+          <a:prstGeom prst="rightArrow">
+            <a:avLst/>
+          </a:prstGeom>
+        </p:spPr>
+        <p:style>
+          <a:lnRef idx="2">
+            <a:schemeClr val="accent1">
+              <a:shade val="50000"/>
+            </a:schemeClr>
+          </a:lnRef>
+          <a:fillRef idx="1">
+            <a:schemeClr val="accent1"/>
+          </a:fillRef>
+          <a:effectRef idx="0">
+            <a:schemeClr val="accent1"/>
+          </a:effectRef>
+          <a:fontRef idx="minor">
+            <a:schemeClr val="lt1"/>
+          </a:fontRef>
+        </p:style>
+        <p:txBody>
+          <a:bodyPr rtlCol="0" anchor="ctr"/>
+          <a:lstStyle/>
+          <a:p>
+            <a:pPr algn="ctr"/>
+            <a:endParaRPr lang="en-US"/>
+          </a:p>
+        </p:txBody>
+      </p:sp>
+      <p:sp>
+        <p:nvSpPr>
+          <p:cNvPr id="28" name="Arrow: Right 27">
+            <a:hlinkClick r:id="rId13" action="ppaction://hlinksldjump" highlightClick="1"/>
+            <a:extLst>
+              <a:ext uri="{FF2B5EF4-FFF2-40B4-BE49-F238E27FC236}">
+                <a16:creationId xmlns:a16="http://schemas.microsoft.com/office/drawing/2014/main" id="{34A0D241-6694-4416-96B2-9C770336D2D5}"/>
+              </a:ext>
+            </a:extLst>
+          </p:cNvPr>
+          <p:cNvSpPr/>
+          <p:nvPr/>
+        </p:nvSpPr>
+        <p:spPr>
+          <a:xfrm rot="10800000">
+            <a:off x="152124" y="6367552"/>
+            <a:ext cx="410649" cy="382385"/>
           </a:xfrm>
           <a:prstGeom prst="rightArrow">
             <a:avLst/>

</xml_diff>